<commit_message>
docs(pitch): reflect the Body tab, data enrichment and demo patient decision
- Demo and proof slides now cite the in-app Body view (nine systems, consent-
  gated, licensed 3D figure) instead of only the prototype trend cards
- Speaker notes: which code runs which pillar after the Body tab landed;
  enrichment caveat for slide 1 numbers; Amira Khan recommendation flagged
</commit_message>
<xml_diff>
--- a/pitch/Kindred-pitch.pptx
+++ b/pitch/Kindred-pitch.pptx
@@ -6996,7 +6996,7 @@
                 </a:solidFill>
                 <a:latin typeface="Instrument Sans"/>
               </a:rPr>
-              <a:t>Proactive, longitudinal. A year of bloods and a week of watch data become improving, watch, worsening.</a:t>
+              <a:t>Proactive, longitudinal. A year of bloods and a week of watch data become improving, watch, worsening, on the Home boxes and a nine-system Body view.</a:t>
             </a:r>
           </a:p>
         </p:txBody>
@@ -9052,7 +9052,7 @@
                 </a:solidFill>
                 <a:latin typeface="Instrument Sans"/>
               </a:rPr>
-              <a:t>Eleanor's trend cards, </a:t>
+              <a:t>Eleanor's body. </a:t>
             </a:r>
             <a:r>
               <a:rPr sz="1450" b="0">
@@ -9061,7 +9061,7 @@
                 </a:solidFill>
                 <a:latin typeface="Instrument Sans"/>
               </a:rPr>
-              <a:t>improving / watch / worsening, generated from her real panel history.  </a:t>
+              <a:t>Nine systems coloured from her live record in the Body tab, consent-gated per system; the Home boxes say what needs watching. Trend cards  </a:t>
             </a:r>
             <a:r>
               <a:rPr sz="850" b="1">
@@ -10644,7 +10644,7 @@
                 </a:solidFill>
                 <a:latin typeface="Bricolage Grotesque"/>
               </a:rPr>
-              <a:t>6</a:t>
+              <a:t>9</a:t>
             </a:r>
           </a:p>
         </p:txBody>
@@ -10686,7 +10686,7 @@
                 </a:solidFill>
                 <a:latin typeface="Instrument Sans"/>
               </a:rPr>
-              <a:t>plain-English trend cards from a year of bloods and the watch data in her record</a:t>
+              <a:t>body systems coloured from the live record, consent-gated per system, on a licensed 3D figure</a:t>
             </a:r>
           </a:p>
         </p:txBody>
@@ -10869,7 +10869,7 @@
                 </a:solidFill>
                 <a:latin typeface="Instrument Sans"/>
               </a:rPr>
-              <a:t>fold the trend engine, the gate and the escalation, prototyped today against the live Anima world, into the app. Pilot at one practice. Wire consent to NHS App proxy access.</a:t>
+              <a:t>fold the disclosure gate, the escalation and the 30-day trend rules, prototyped today against the live Anima world, into the app's scheduled check. Pilot at one practice. Wire consent to NHS App proxy access.</a:t>
             </a:r>
           </a:p>
         </p:txBody>

</xml_diff>